<commit_message>
HW TCA decks: method slide and notes cover the pin view, E1-E10 and D from 1 to 10
Co-Authored-By: Claude Opus 5.5 <noreply@anthropic.com>
Claude-Session: https://claude.ai/code/session_015jZV3M7jRAYSoYnq2E89o1
</commit_message>
<xml_diff>
--- a/materials/HW_TCA_curs_RO.pptx
+++ b/materials/HW_TCA_curs_RO.pptx
@@ -1248,7 +1248,7 @@
             <a:r>
               <a:rPr lang="en-US" dirty="0"/>
               <a:t>Acum partea practică. Fiecare primește o variantă, de la H1 la H6, cu 12 moduri de defectare ale modulului.
-Pentru fiecare mod: alegeți clasa de efect, iar severitatea rezultă din ea. Alegeți ocurența din tabelul AIAG-VDA; pentru o tehnologie SMT matură e de obicei mică. Pentru AOI, AXI și ICT, aplicația calculează detecția din regulile de detecție și vă arată motivul. Pentru testul funcțional alegeți din lista FT1–FT8 testul care prinde defectul, sau NONE, dați valoarea D și scrieți de ce. Folosiți schema din aplicație.
+Pentru fiecare mod: alegeți clasa de efect, iar severitatea rezultă din ea. Alegeți ocurența din tabelul AIAG-VDA; pentru o tehnologie SMT matură e de obicei mică. Pentru AOI, AXI și ICT, aplicația calculează detecția din regulile de detecție și vă arată motivul. Pentru testul funcțional, apăsați pe pinul componentei, pe placă sau în schemă: aplicația desenează netul acelui pin și arată, în panoul Conexiuni, dacă ajunge la un conector, adică dacă testul funcțional îl poate vedea, și dacă are test point. Apoi alegeți din lista FT1–FT8 testul care prinde defectul, sau NONE, alegeți D de la 1 la 10 din scala de detecție AIAG-VDA, ale cărei descrieri apar în listă, și scrieți de ce.
 Detecția combinată este minimul dintre metode, iar AP rezultă din tabel. Apoi propuneți îmbunătățiri: test point-uri, AOI pe fața de jos sau teste funcționale noi, și urmăriți cum scade riscul. Unde AP rămâne H sau M, documentați riscul rezidual. La final, trimiteți raportul din aplicație.</a:t>
             </a:r>
             <a:endParaRPr lang="en-US" dirty="0"/>
@@ -9234,7 +9234,7 @@
                   <a:srgbClr val="5B6575"/>
                 </a:solidFill>
               </a:rPr>
-              <a:t>alegeți clasa de efect (E1–E9), S rezultă din ea</a:t>
+              <a:t>alegeți clasa de efect (E1–E10), S rezultă din ea</a:t>
             </a:r>
             <a:endParaRPr lang="en-US" sz="1300" dirty="0"/>
           </a:p>
@@ -9558,7 +9558,7 @@
                   <a:srgbClr val="5B6575"/>
                 </a:solidFill>
               </a:rPr>
-              <a:t>alegeți testul FT1–FT8 sau NONE, D și justificarea</a:t>
+              <a:t>urmăriți netul pinului, alegeți testul FT1–FT8 sau NONE, D de la 1 la 10 și justificarea</a:t>
             </a:r>
             <a:endParaRPr lang="en-US" sz="1300" dirty="0"/>
           </a:p>

</xml_diff>